<commit_message>
Expand demo deck to 35 slides with Cognitive Enterprise Platform vision
Add 15 elaborate slides (21-35) in a layered, swim-lane style:
- Cognitive Enterprise Platform blueprint (business surface →
  orchestration → agent ecosystem → memory → data/LLMOps)
- Business value streams, AI Centre of Excellence, federated
  operating model, A2A protocol flow, memory deep dive, data
  foundation & LLMOps, spike-to-platform mapping, security/RAI,
  FinOps, personas, maturity model, roadmap, ROI and closing

Make footer slide count dynamic (35), refresh PDF/PPTX and all assets.

https://claude.ai/code/session_01KBzAxeZ5kgTaMaFHRbMpLQ
</commit_message>
<xml_diff>
--- a/repo/docs/slides/ai-factory-demo.pptx
+++ b/repo/docs/slides/ai-factory-demo.pptx
@@ -25,6 +25,21 @@
     <p:sldId id="273" r:id="rId24"/>
     <p:sldId id="274" r:id="rId25"/>
     <p:sldId id="275" r:id="rId26"/>
+    <p:sldId id="276" r:id="rId27"/>
+    <p:sldId id="277" r:id="rId28"/>
+    <p:sldId id="278" r:id="rId29"/>
+    <p:sldId id="279" r:id="rId30"/>
+    <p:sldId id="280" r:id="rId31"/>
+    <p:sldId id="281" r:id="rId32"/>
+    <p:sldId id="282" r:id="rId33"/>
+    <p:sldId id="283" r:id="rId34"/>
+    <p:sldId id="284" r:id="rId35"/>
+    <p:sldId id="285" r:id="rId36"/>
+    <p:sldId id="286" r:id="rId37"/>
+    <p:sldId id="287" r:id="rId38"/>
+    <p:sldId id="288" r:id="rId39"/>
+    <p:sldId id="289" r:id="rId40"/>
+    <p:sldId id="290" r:id="rId41"/>
   </p:sldIdLst>
   <p:sldSz cx="12191695" cy="6858000" type="screen4x3"/>
   <p:notesSz cx="6858000" cy="9144000"/>
@@ -3643,6 +3658,384 @@
 </p:sld>
 </file>
 
+<file path=ppt/slides/slide21.xml><?xml version="1.0" encoding="utf-8"?>
+<p:sld xmlns:a="http://schemas.openxmlformats.org/drawingml/2006/main" xmlns:p="http://schemas.openxmlformats.org/presentationml/2006/main" xmlns:r="http://schemas.openxmlformats.org/officeDocument/2006/relationships">
+  <p:cSld>
+    <p:spTree>
+      <p:nvGrpSpPr>
+        <p:cNvPr id="1" name=""/>
+        <p:cNvGrpSpPr/>
+        <p:nvPr/>
+      </p:nvGrpSpPr>
+      <p:grpSpPr/>
+      <p:pic>
+        <p:nvPicPr>
+          <p:cNvPr id="2" name="Picture 1" descr="slide_21.png"/>
+          <p:cNvPicPr>
+            <a:picLocks noChangeAspect="1"/>
+          </p:cNvPicPr>
+          <p:nvPr/>
+        </p:nvPicPr>
+        <p:blipFill>
+          <a:blip r:embed="rId2"/>
+          <a:stretch>
+            <a:fillRect/>
+          </a:stretch>
+        </p:blipFill>
+        <p:spPr>
+          <a:xfrm>
+            <a:off x="0" y="0"/>
+            <a:ext cx="12191695" cy="6858000"/>
+          </a:xfrm>
+          <a:prstGeom prst="rect">
+            <a:avLst/>
+          </a:prstGeom>
+        </p:spPr>
+      </p:pic>
+    </p:spTree>
+  </p:cSld>
+  <p:clrMapOvr>
+    <a:masterClrMapping/>
+  </p:clrMapOvr>
+</p:sld>
+</file>
+
+<file path=ppt/slides/slide22.xml><?xml version="1.0" encoding="utf-8"?>
+<p:sld xmlns:a="http://schemas.openxmlformats.org/drawingml/2006/main" xmlns:p="http://schemas.openxmlformats.org/presentationml/2006/main" xmlns:r="http://schemas.openxmlformats.org/officeDocument/2006/relationships">
+  <p:cSld>
+    <p:spTree>
+      <p:nvGrpSpPr>
+        <p:cNvPr id="1" name=""/>
+        <p:cNvGrpSpPr/>
+        <p:nvPr/>
+      </p:nvGrpSpPr>
+      <p:grpSpPr/>
+      <p:pic>
+        <p:nvPicPr>
+          <p:cNvPr id="2" name="Picture 1" descr="slide_22.png"/>
+          <p:cNvPicPr>
+            <a:picLocks noChangeAspect="1"/>
+          </p:cNvPicPr>
+          <p:nvPr/>
+        </p:nvPicPr>
+        <p:blipFill>
+          <a:blip r:embed="rId2"/>
+          <a:stretch>
+            <a:fillRect/>
+          </a:stretch>
+        </p:blipFill>
+        <p:spPr>
+          <a:xfrm>
+            <a:off x="0" y="0"/>
+            <a:ext cx="12191695" cy="6858000"/>
+          </a:xfrm>
+          <a:prstGeom prst="rect">
+            <a:avLst/>
+          </a:prstGeom>
+        </p:spPr>
+      </p:pic>
+    </p:spTree>
+  </p:cSld>
+  <p:clrMapOvr>
+    <a:masterClrMapping/>
+  </p:clrMapOvr>
+</p:sld>
+</file>
+
+<file path=ppt/slides/slide23.xml><?xml version="1.0" encoding="utf-8"?>
+<p:sld xmlns:a="http://schemas.openxmlformats.org/drawingml/2006/main" xmlns:p="http://schemas.openxmlformats.org/presentationml/2006/main" xmlns:r="http://schemas.openxmlformats.org/officeDocument/2006/relationships">
+  <p:cSld>
+    <p:spTree>
+      <p:nvGrpSpPr>
+        <p:cNvPr id="1" name=""/>
+        <p:cNvGrpSpPr/>
+        <p:nvPr/>
+      </p:nvGrpSpPr>
+      <p:grpSpPr/>
+      <p:pic>
+        <p:nvPicPr>
+          <p:cNvPr id="2" name="Picture 1" descr="slide_23.png"/>
+          <p:cNvPicPr>
+            <a:picLocks noChangeAspect="1"/>
+          </p:cNvPicPr>
+          <p:nvPr/>
+        </p:nvPicPr>
+        <p:blipFill>
+          <a:blip r:embed="rId2"/>
+          <a:stretch>
+            <a:fillRect/>
+          </a:stretch>
+        </p:blipFill>
+        <p:spPr>
+          <a:xfrm>
+            <a:off x="0" y="0"/>
+            <a:ext cx="12191695" cy="6858000"/>
+          </a:xfrm>
+          <a:prstGeom prst="rect">
+            <a:avLst/>
+          </a:prstGeom>
+        </p:spPr>
+      </p:pic>
+    </p:spTree>
+  </p:cSld>
+  <p:clrMapOvr>
+    <a:masterClrMapping/>
+  </p:clrMapOvr>
+</p:sld>
+</file>
+
+<file path=ppt/slides/slide24.xml><?xml version="1.0" encoding="utf-8"?>
+<p:sld xmlns:a="http://schemas.openxmlformats.org/drawingml/2006/main" xmlns:p="http://schemas.openxmlformats.org/presentationml/2006/main" xmlns:r="http://schemas.openxmlformats.org/officeDocument/2006/relationships">
+  <p:cSld>
+    <p:spTree>
+      <p:nvGrpSpPr>
+        <p:cNvPr id="1" name=""/>
+        <p:cNvGrpSpPr/>
+        <p:nvPr/>
+      </p:nvGrpSpPr>
+      <p:grpSpPr/>
+      <p:pic>
+        <p:nvPicPr>
+          <p:cNvPr id="2" name="Picture 1" descr="slide_24.png"/>
+          <p:cNvPicPr>
+            <a:picLocks noChangeAspect="1"/>
+          </p:cNvPicPr>
+          <p:nvPr/>
+        </p:nvPicPr>
+        <p:blipFill>
+          <a:blip r:embed="rId2"/>
+          <a:stretch>
+            <a:fillRect/>
+          </a:stretch>
+        </p:blipFill>
+        <p:spPr>
+          <a:xfrm>
+            <a:off x="0" y="0"/>
+            <a:ext cx="12191695" cy="6858000"/>
+          </a:xfrm>
+          <a:prstGeom prst="rect">
+            <a:avLst/>
+          </a:prstGeom>
+        </p:spPr>
+      </p:pic>
+    </p:spTree>
+  </p:cSld>
+  <p:clrMapOvr>
+    <a:masterClrMapping/>
+  </p:clrMapOvr>
+</p:sld>
+</file>
+
+<file path=ppt/slides/slide25.xml><?xml version="1.0" encoding="utf-8"?>
+<p:sld xmlns:a="http://schemas.openxmlformats.org/drawingml/2006/main" xmlns:p="http://schemas.openxmlformats.org/presentationml/2006/main" xmlns:r="http://schemas.openxmlformats.org/officeDocument/2006/relationships">
+  <p:cSld>
+    <p:spTree>
+      <p:nvGrpSpPr>
+        <p:cNvPr id="1" name=""/>
+        <p:cNvGrpSpPr/>
+        <p:nvPr/>
+      </p:nvGrpSpPr>
+      <p:grpSpPr/>
+      <p:pic>
+        <p:nvPicPr>
+          <p:cNvPr id="2" name="Picture 1" descr="slide_25.png"/>
+          <p:cNvPicPr>
+            <a:picLocks noChangeAspect="1"/>
+          </p:cNvPicPr>
+          <p:nvPr/>
+        </p:nvPicPr>
+        <p:blipFill>
+          <a:blip r:embed="rId2"/>
+          <a:stretch>
+            <a:fillRect/>
+          </a:stretch>
+        </p:blipFill>
+        <p:spPr>
+          <a:xfrm>
+            <a:off x="0" y="0"/>
+            <a:ext cx="12191695" cy="6858000"/>
+          </a:xfrm>
+          <a:prstGeom prst="rect">
+            <a:avLst/>
+          </a:prstGeom>
+        </p:spPr>
+      </p:pic>
+    </p:spTree>
+  </p:cSld>
+  <p:clrMapOvr>
+    <a:masterClrMapping/>
+  </p:clrMapOvr>
+</p:sld>
+</file>
+
+<file path=ppt/slides/slide26.xml><?xml version="1.0" encoding="utf-8"?>
+<p:sld xmlns:a="http://schemas.openxmlformats.org/drawingml/2006/main" xmlns:p="http://schemas.openxmlformats.org/presentationml/2006/main" xmlns:r="http://schemas.openxmlformats.org/officeDocument/2006/relationships">
+  <p:cSld>
+    <p:spTree>
+      <p:nvGrpSpPr>
+        <p:cNvPr id="1" name=""/>
+        <p:cNvGrpSpPr/>
+        <p:nvPr/>
+      </p:nvGrpSpPr>
+      <p:grpSpPr/>
+      <p:pic>
+        <p:nvPicPr>
+          <p:cNvPr id="2" name="Picture 1" descr="slide_26.png"/>
+          <p:cNvPicPr>
+            <a:picLocks noChangeAspect="1"/>
+          </p:cNvPicPr>
+          <p:nvPr/>
+        </p:nvPicPr>
+        <p:blipFill>
+          <a:blip r:embed="rId2"/>
+          <a:stretch>
+            <a:fillRect/>
+          </a:stretch>
+        </p:blipFill>
+        <p:spPr>
+          <a:xfrm>
+            <a:off x="0" y="0"/>
+            <a:ext cx="12191695" cy="6858000"/>
+          </a:xfrm>
+          <a:prstGeom prst="rect">
+            <a:avLst/>
+          </a:prstGeom>
+        </p:spPr>
+      </p:pic>
+    </p:spTree>
+  </p:cSld>
+  <p:clrMapOvr>
+    <a:masterClrMapping/>
+  </p:clrMapOvr>
+</p:sld>
+</file>
+
+<file path=ppt/slides/slide27.xml><?xml version="1.0" encoding="utf-8"?>
+<p:sld xmlns:a="http://schemas.openxmlformats.org/drawingml/2006/main" xmlns:p="http://schemas.openxmlformats.org/presentationml/2006/main" xmlns:r="http://schemas.openxmlformats.org/officeDocument/2006/relationships">
+  <p:cSld>
+    <p:spTree>
+      <p:nvGrpSpPr>
+        <p:cNvPr id="1" name=""/>
+        <p:cNvGrpSpPr/>
+        <p:nvPr/>
+      </p:nvGrpSpPr>
+      <p:grpSpPr/>
+      <p:pic>
+        <p:nvPicPr>
+          <p:cNvPr id="2" name="Picture 1" descr="slide_27.png"/>
+          <p:cNvPicPr>
+            <a:picLocks noChangeAspect="1"/>
+          </p:cNvPicPr>
+          <p:nvPr/>
+        </p:nvPicPr>
+        <p:blipFill>
+          <a:blip r:embed="rId2"/>
+          <a:stretch>
+            <a:fillRect/>
+          </a:stretch>
+        </p:blipFill>
+        <p:spPr>
+          <a:xfrm>
+            <a:off x="0" y="0"/>
+            <a:ext cx="12191695" cy="6858000"/>
+          </a:xfrm>
+          <a:prstGeom prst="rect">
+            <a:avLst/>
+          </a:prstGeom>
+        </p:spPr>
+      </p:pic>
+    </p:spTree>
+  </p:cSld>
+  <p:clrMapOvr>
+    <a:masterClrMapping/>
+  </p:clrMapOvr>
+</p:sld>
+</file>
+
+<file path=ppt/slides/slide28.xml><?xml version="1.0" encoding="utf-8"?>
+<p:sld xmlns:a="http://schemas.openxmlformats.org/drawingml/2006/main" xmlns:p="http://schemas.openxmlformats.org/presentationml/2006/main" xmlns:r="http://schemas.openxmlformats.org/officeDocument/2006/relationships">
+  <p:cSld>
+    <p:spTree>
+      <p:nvGrpSpPr>
+        <p:cNvPr id="1" name=""/>
+        <p:cNvGrpSpPr/>
+        <p:nvPr/>
+      </p:nvGrpSpPr>
+      <p:grpSpPr/>
+      <p:pic>
+        <p:nvPicPr>
+          <p:cNvPr id="2" name="Picture 1" descr="slide_28.png"/>
+          <p:cNvPicPr>
+            <a:picLocks noChangeAspect="1"/>
+          </p:cNvPicPr>
+          <p:nvPr/>
+        </p:nvPicPr>
+        <p:blipFill>
+          <a:blip r:embed="rId2"/>
+          <a:stretch>
+            <a:fillRect/>
+          </a:stretch>
+        </p:blipFill>
+        <p:spPr>
+          <a:xfrm>
+            <a:off x="0" y="0"/>
+            <a:ext cx="12191695" cy="6858000"/>
+          </a:xfrm>
+          <a:prstGeom prst="rect">
+            <a:avLst/>
+          </a:prstGeom>
+        </p:spPr>
+      </p:pic>
+    </p:spTree>
+  </p:cSld>
+  <p:clrMapOvr>
+    <a:masterClrMapping/>
+  </p:clrMapOvr>
+</p:sld>
+</file>
+
+<file path=ppt/slides/slide29.xml><?xml version="1.0" encoding="utf-8"?>
+<p:sld xmlns:a="http://schemas.openxmlformats.org/drawingml/2006/main" xmlns:p="http://schemas.openxmlformats.org/presentationml/2006/main" xmlns:r="http://schemas.openxmlformats.org/officeDocument/2006/relationships">
+  <p:cSld>
+    <p:spTree>
+      <p:nvGrpSpPr>
+        <p:cNvPr id="1" name=""/>
+        <p:cNvGrpSpPr/>
+        <p:nvPr/>
+      </p:nvGrpSpPr>
+      <p:grpSpPr/>
+      <p:pic>
+        <p:nvPicPr>
+          <p:cNvPr id="2" name="Picture 1" descr="slide_29.png"/>
+          <p:cNvPicPr>
+            <a:picLocks noChangeAspect="1"/>
+          </p:cNvPicPr>
+          <p:nvPr/>
+        </p:nvPicPr>
+        <p:blipFill>
+          <a:blip r:embed="rId2"/>
+          <a:stretch>
+            <a:fillRect/>
+          </a:stretch>
+        </p:blipFill>
+        <p:spPr>
+          <a:xfrm>
+            <a:off x="0" y="0"/>
+            <a:ext cx="12191695" cy="6858000"/>
+          </a:xfrm>
+          <a:prstGeom prst="rect">
+            <a:avLst/>
+          </a:prstGeom>
+        </p:spPr>
+      </p:pic>
+    </p:spTree>
+  </p:cSld>
+  <p:clrMapOvr>
+    <a:masterClrMapping/>
+  </p:clrMapOvr>
+</p:sld>
+</file>
+
 <file path=ppt/slides/slide3.xml><?xml version="1.0" encoding="utf-8"?>
 <p:sld xmlns:a="http://schemas.openxmlformats.org/drawingml/2006/main" xmlns:p="http://schemas.openxmlformats.org/presentationml/2006/main" xmlns:r="http://schemas.openxmlformats.org/officeDocument/2006/relationships">
   <p:cSld>
@@ -3656,6 +4049,258 @@
       <p:pic>
         <p:nvPicPr>
           <p:cNvPr id="2" name="Picture 1" descr="slide_03.png"/>
+          <p:cNvPicPr>
+            <a:picLocks noChangeAspect="1"/>
+          </p:cNvPicPr>
+          <p:nvPr/>
+        </p:nvPicPr>
+        <p:blipFill>
+          <a:blip r:embed="rId2"/>
+          <a:stretch>
+            <a:fillRect/>
+          </a:stretch>
+        </p:blipFill>
+        <p:spPr>
+          <a:xfrm>
+            <a:off x="0" y="0"/>
+            <a:ext cx="12191695" cy="6858000"/>
+          </a:xfrm>
+          <a:prstGeom prst="rect">
+            <a:avLst/>
+          </a:prstGeom>
+        </p:spPr>
+      </p:pic>
+    </p:spTree>
+  </p:cSld>
+  <p:clrMapOvr>
+    <a:masterClrMapping/>
+  </p:clrMapOvr>
+</p:sld>
+</file>
+
+<file path=ppt/slides/slide30.xml><?xml version="1.0" encoding="utf-8"?>
+<p:sld xmlns:a="http://schemas.openxmlformats.org/drawingml/2006/main" xmlns:p="http://schemas.openxmlformats.org/presentationml/2006/main" xmlns:r="http://schemas.openxmlformats.org/officeDocument/2006/relationships">
+  <p:cSld>
+    <p:spTree>
+      <p:nvGrpSpPr>
+        <p:cNvPr id="1" name=""/>
+        <p:cNvGrpSpPr/>
+        <p:nvPr/>
+      </p:nvGrpSpPr>
+      <p:grpSpPr/>
+      <p:pic>
+        <p:nvPicPr>
+          <p:cNvPr id="2" name="Picture 1" descr="slide_30.png"/>
+          <p:cNvPicPr>
+            <a:picLocks noChangeAspect="1"/>
+          </p:cNvPicPr>
+          <p:nvPr/>
+        </p:nvPicPr>
+        <p:blipFill>
+          <a:blip r:embed="rId2"/>
+          <a:stretch>
+            <a:fillRect/>
+          </a:stretch>
+        </p:blipFill>
+        <p:spPr>
+          <a:xfrm>
+            <a:off x="0" y="0"/>
+            <a:ext cx="12191695" cy="6858000"/>
+          </a:xfrm>
+          <a:prstGeom prst="rect">
+            <a:avLst/>
+          </a:prstGeom>
+        </p:spPr>
+      </p:pic>
+    </p:spTree>
+  </p:cSld>
+  <p:clrMapOvr>
+    <a:masterClrMapping/>
+  </p:clrMapOvr>
+</p:sld>
+</file>
+
+<file path=ppt/slides/slide31.xml><?xml version="1.0" encoding="utf-8"?>
+<p:sld xmlns:a="http://schemas.openxmlformats.org/drawingml/2006/main" xmlns:p="http://schemas.openxmlformats.org/presentationml/2006/main" xmlns:r="http://schemas.openxmlformats.org/officeDocument/2006/relationships">
+  <p:cSld>
+    <p:spTree>
+      <p:nvGrpSpPr>
+        <p:cNvPr id="1" name=""/>
+        <p:cNvGrpSpPr/>
+        <p:nvPr/>
+      </p:nvGrpSpPr>
+      <p:grpSpPr/>
+      <p:pic>
+        <p:nvPicPr>
+          <p:cNvPr id="2" name="Picture 1" descr="slide_31.png"/>
+          <p:cNvPicPr>
+            <a:picLocks noChangeAspect="1"/>
+          </p:cNvPicPr>
+          <p:nvPr/>
+        </p:nvPicPr>
+        <p:blipFill>
+          <a:blip r:embed="rId2"/>
+          <a:stretch>
+            <a:fillRect/>
+          </a:stretch>
+        </p:blipFill>
+        <p:spPr>
+          <a:xfrm>
+            <a:off x="0" y="0"/>
+            <a:ext cx="12191695" cy="6858000"/>
+          </a:xfrm>
+          <a:prstGeom prst="rect">
+            <a:avLst/>
+          </a:prstGeom>
+        </p:spPr>
+      </p:pic>
+    </p:spTree>
+  </p:cSld>
+  <p:clrMapOvr>
+    <a:masterClrMapping/>
+  </p:clrMapOvr>
+</p:sld>
+</file>
+
+<file path=ppt/slides/slide32.xml><?xml version="1.0" encoding="utf-8"?>
+<p:sld xmlns:a="http://schemas.openxmlformats.org/drawingml/2006/main" xmlns:p="http://schemas.openxmlformats.org/presentationml/2006/main" xmlns:r="http://schemas.openxmlformats.org/officeDocument/2006/relationships">
+  <p:cSld>
+    <p:spTree>
+      <p:nvGrpSpPr>
+        <p:cNvPr id="1" name=""/>
+        <p:cNvGrpSpPr/>
+        <p:nvPr/>
+      </p:nvGrpSpPr>
+      <p:grpSpPr/>
+      <p:pic>
+        <p:nvPicPr>
+          <p:cNvPr id="2" name="Picture 1" descr="slide_32.png"/>
+          <p:cNvPicPr>
+            <a:picLocks noChangeAspect="1"/>
+          </p:cNvPicPr>
+          <p:nvPr/>
+        </p:nvPicPr>
+        <p:blipFill>
+          <a:blip r:embed="rId2"/>
+          <a:stretch>
+            <a:fillRect/>
+          </a:stretch>
+        </p:blipFill>
+        <p:spPr>
+          <a:xfrm>
+            <a:off x="0" y="0"/>
+            <a:ext cx="12191695" cy="6858000"/>
+          </a:xfrm>
+          <a:prstGeom prst="rect">
+            <a:avLst/>
+          </a:prstGeom>
+        </p:spPr>
+      </p:pic>
+    </p:spTree>
+  </p:cSld>
+  <p:clrMapOvr>
+    <a:masterClrMapping/>
+  </p:clrMapOvr>
+</p:sld>
+</file>
+
+<file path=ppt/slides/slide33.xml><?xml version="1.0" encoding="utf-8"?>
+<p:sld xmlns:a="http://schemas.openxmlformats.org/drawingml/2006/main" xmlns:p="http://schemas.openxmlformats.org/presentationml/2006/main" xmlns:r="http://schemas.openxmlformats.org/officeDocument/2006/relationships">
+  <p:cSld>
+    <p:spTree>
+      <p:nvGrpSpPr>
+        <p:cNvPr id="1" name=""/>
+        <p:cNvGrpSpPr/>
+        <p:nvPr/>
+      </p:nvGrpSpPr>
+      <p:grpSpPr/>
+      <p:pic>
+        <p:nvPicPr>
+          <p:cNvPr id="2" name="Picture 1" descr="slide_33.png"/>
+          <p:cNvPicPr>
+            <a:picLocks noChangeAspect="1"/>
+          </p:cNvPicPr>
+          <p:nvPr/>
+        </p:nvPicPr>
+        <p:blipFill>
+          <a:blip r:embed="rId2"/>
+          <a:stretch>
+            <a:fillRect/>
+          </a:stretch>
+        </p:blipFill>
+        <p:spPr>
+          <a:xfrm>
+            <a:off x="0" y="0"/>
+            <a:ext cx="12191695" cy="6858000"/>
+          </a:xfrm>
+          <a:prstGeom prst="rect">
+            <a:avLst/>
+          </a:prstGeom>
+        </p:spPr>
+      </p:pic>
+    </p:spTree>
+  </p:cSld>
+  <p:clrMapOvr>
+    <a:masterClrMapping/>
+  </p:clrMapOvr>
+</p:sld>
+</file>
+
+<file path=ppt/slides/slide34.xml><?xml version="1.0" encoding="utf-8"?>
+<p:sld xmlns:a="http://schemas.openxmlformats.org/drawingml/2006/main" xmlns:p="http://schemas.openxmlformats.org/presentationml/2006/main" xmlns:r="http://schemas.openxmlformats.org/officeDocument/2006/relationships">
+  <p:cSld>
+    <p:spTree>
+      <p:nvGrpSpPr>
+        <p:cNvPr id="1" name=""/>
+        <p:cNvGrpSpPr/>
+        <p:nvPr/>
+      </p:nvGrpSpPr>
+      <p:grpSpPr/>
+      <p:pic>
+        <p:nvPicPr>
+          <p:cNvPr id="2" name="Picture 1" descr="slide_34.png"/>
+          <p:cNvPicPr>
+            <a:picLocks noChangeAspect="1"/>
+          </p:cNvPicPr>
+          <p:nvPr/>
+        </p:nvPicPr>
+        <p:blipFill>
+          <a:blip r:embed="rId2"/>
+          <a:stretch>
+            <a:fillRect/>
+          </a:stretch>
+        </p:blipFill>
+        <p:spPr>
+          <a:xfrm>
+            <a:off x="0" y="0"/>
+            <a:ext cx="12191695" cy="6858000"/>
+          </a:xfrm>
+          <a:prstGeom prst="rect">
+            <a:avLst/>
+          </a:prstGeom>
+        </p:spPr>
+      </p:pic>
+    </p:spTree>
+  </p:cSld>
+  <p:clrMapOvr>
+    <a:masterClrMapping/>
+  </p:clrMapOvr>
+</p:sld>
+</file>
+
+<file path=ppt/slides/slide35.xml><?xml version="1.0" encoding="utf-8"?>
+<p:sld xmlns:a="http://schemas.openxmlformats.org/drawingml/2006/main" xmlns:p="http://schemas.openxmlformats.org/presentationml/2006/main" xmlns:r="http://schemas.openxmlformats.org/officeDocument/2006/relationships">
+  <p:cSld>
+    <p:spTree>
+      <p:nvGrpSpPr>
+        <p:cNvPr id="1" name=""/>
+        <p:cNvGrpSpPr/>
+        <p:nvPr/>
+      </p:nvGrpSpPr>
+      <p:grpSpPr/>
+      <p:pic>
+        <p:nvPicPr>
+          <p:cNvPr id="2" name="Picture 1" descr="slide_35.png"/>
           <p:cNvPicPr>
             <a:picLocks noChangeAspect="1"/>
           </p:cNvPicPr>

</xml_diff>